<commit_message>
Update presentation: new user stories, layout fixes, add grill phase
Co-Authored-By: Claude Opus 4.6 (1M context) <noreply@anthropic.com>
</commit_message>
<xml_diff>
--- a/docs/presentation.pptx
+++ b/docs/presentation.pptx
@@ -3398,7 +3398,7 @@
               </a:defRPr>
             </a:pPr>
             <a:r>
-              <a:t>   /story-to-feature — five phases, zero intervention</a:t>
+              <a:t>   /story-to-feature — six phases, zero intervention</a:t>
             </a:r>
           </a:p>
         </p:txBody>
@@ -3411,8 +3411,8 @@
         </p:nvSpPr>
         <p:spPr>
           <a:xfrm>
-            <a:off x="1371600" y="1645920"/>
-            <a:ext cx="9144000" cy="1097280"/>
+            <a:off x="457200" y="1645920"/>
+            <a:ext cx="3474720" cy="1097280"/>
           </a:xfrm>
           <a:prstGeom prst="roundRect">
             <a:avLst/>
@@ -3455,14 +3455,14 @@
         </p:nvSpPr>
         <p:spPr>
           <a:xfrm>
-            <a:off x="1600200" y="1828800"/>
+            <a:off x="685800" y="1828800"/>
             <a:ext cx="548640" cy="548640"/>
           </a:xfrm>
           <a:prstGeom prst="ellipse">
             <a:avLst/>
           </a:prstGeom>
           <a:solidFill>
-            <a:srgbClr val="00A1E0"/>
+            <a:srgbClr val="00BCD4"/>
           </a:solidFill>
           <a:ln>
             <a:noFill/>
@@ -3495,7 +3495,7 @@
               </a:defRPr>
             </a:pPr>
             <a:r>
-              <a:t>1</a:t>
+              <a:t>0</a:t>
             </a:r>
           </a:p>
         </p:txBody>
@@ -3508,8 +3508,8 @@
         </p:nvSpPr>
         <p:spPr>
           <a:xfrm>
-            <a:off x="2286000" y="1783080"/>
-            <a:ext cx="7955280" cy="365760"/>
+            <a:off x="1371600" y="1783080"/>
+            <a:ext cx="2286000" cy="365760"/>
           </a:xfrm>
           <a:prstGeom prst="rect">
             <a:avLst/>
@@ -3531,7 +3531,7 @@
               </a:defRPr>
             </a:pPr>
             <a:r>
-              <a:t>Architect</a:t>
+              <a:t>Grill</a:t>
             </a:r>
           </a:p>
         </p:txBody>
@@ -3544,8 +3544,8 @@
         </p:nvSpPr>
         <p:spPr>
           <a:xfrm>
-            <a:off x="2286000" y="2194560"/>
-            <a:ext cx="7955280" cy="457200"/>
+            <a:off x="1371600" y="2194560"/>
+            <a:ext cx="2286000" cy="457200"/>
           </a:xfrm>
           <a:prstGeom prst="rect">
             <a:avLst/>
@@ -3559,7 +3559,7 @@
           <a:lstStyle/>
           <a:p>
             <a:pPr algn="l">
-              <a:defRPr sz="1400" b="0">
+              <a:defRPr sz="1600" b="0">
                 <a:solidFill>
                   <a:srgbClr val="888899"/>
                 </a:solidFill>
@@ -3567,11 +3567,11 @@
               </a:defRPr>
             </a:pPr>
             <a:r>
-              <a:t>Analyze story, design data model,</a:t>
+              <a:t>Stress-test the story</a:t>
             </a:r>
             <a:br/>
             <a:r>
-              <a:t>plan all artifacts</a:t>
+              <a:t>for gaps &amp; edge cases</a:t>
             </a:r>
           </a:p>
         </p:txBody>
@@ -3584,8 +3584,8 @@
         </p:nvSpPr>
         <p:spPr>
           <a:xfrm>
-            <a:off x="1371600" y="2651760"/>
-            <a:ext cx="9144000" cy="1097280"/>
+            <a:off x="4206239" y="1645920"/>
+            <a:ext cx="3474720" cy="1097280"/>
           </a:xfrm>
           <a:prstGeom prst="roundRect">
             <a:avLst/>
@@ -3628,14 +3628,14 @@
         </p:nvSpPr>
         <p:spPr>
           <a:xfrm>
-            <a:off x="1600200" y="2834640"/>
+            <a:off x="4434839" y="1828800"/>
             <a:ext cx="548640" cy="548640"/>
           </a:xfrm>
           <a:prstGeom prst="ellipse">
             <a:avLst/>
           </a:prstGeom>
           <a:solidFill>
-            <a:srgbClr val="2ECC71"/>
+            <a:srgbClr val="00A1E0"/>
           </a:solidFill>
           <a:ln>
             <a:noFill/>
@@ -3668,7 +3668,7 @@
               </a:defRPr>
             </a:pPr>
             <a:r>
-              <a:t>2</a:t>
+              <a:t>1</a:t>
             </a:r>
           </a:p>
         </p:txBody>
@@ -3681,8 +3681,8 @@
         </p:nvSpPr>
         <p:spPr>
           <a:xfrm>
-            <a:off x="2286000" y="2788920"/>
-            <a:ext cx="7955280" cy="365760"/>
+            <a:off x="5120639" y="1783080"/>
+            <a:ext cx="2286000" cy="365760"/>
           </a:xfrm>
           <a:prstGeom prst="rect">
             <a:avLst/>
@@ -3704,7 +3704,7 @@
               </a:defRPr>
             </a:pPr>
             <a:r>
-              <a:t>Implement</a:t>
+              <a:t>Architect</a:t>
             </a:r>
           </a:p>
         </p:txBody>
@@ -3717,8 +3717,8 @@
         </p:nvSpPr>
         <p:spPr>
           <a:xfrm>
-            <a:off x="2286000" y="3200400"/>
-            <a:ext cx="7955280" cy="457200"/>
+            <a:off x="5120639" y="2194560"/>
+            <a:ext cx="2286000" cy="457200"/>
           </a:xfrm>
           <a:prstGeom prst="rect">
             <a:avLst/>
@@ -3732,7 +3732,7 @@
           <a:lstStyle/>
           <a:p>
             <a:pPr algn="l">
-              <a:defRPr sz="1400" b="0">
+              <a:defRPr sz="1600" b="0">
                 <a:solidFill>
                   <a:srgbClr val="888899"/>
                 </a:solidFill>
@@ -3740,11 +3740,11 @@
               </a:defRPr>
             </a:pPr>
             <a:r>
-              <a:t>Write Apex, LWC, metadata</a:t>
+              <a:t>Design data model</a:t>
             </a:r>
             <a:br/>
             <a:r>
-              <a:t>following CLAUDE.md conventions</a:t>
+              <a:t>and plan all artifacts</a:t>
             </a:r>
           </a:p>
         </p:txBody>
@@ -3757,8 +3757,8 @@
         </p:nvSpPr>
         <p:spPr>
           <a:xfrm>
-            <a:off x="1371600" y="3657600"/>
-            <a:ext cx="9144000" cy="1097280"/>
+            <a:off x="7955278" y="1645920"/>
+            <a:ext cx="3474720" cy="1097280"/>
           </a:xfrm>
           <a:prstGeom prst="roundRect">
             <a:avLst/>
@@ -3801,14 +3801,14 @@
         </p:nvSpPr>
         <p:spPr>
           <a:xfrm>
-            <a:off x="1600200" y="3840480"/>
+            <a:off x="8183878" y="1828800"/>
             <a:ext cx="548640" cy="548640"/>
           </a:xfrm>
           <a:prstGeom prst="ellipse">
             <a:avLst/>
           </a:prstGeom>
           <a:solidFill>
-            <a:srgbClr val="E86C00"/>
+            <a:srgbClr val="2ECC71"/>
           </a:solidFill>
           <a:ln>
             <a:noFill/>
@@ -3841,7 +3841,7 @@
               </a:defRPr>
             </a:pPr>
             <a:r>
-              <a:t>3</a:t>
+              <a:t>2</a:t>
             </a:r>
           </a:p>
         </p:txBody>
@@ -3854,8 +3854,8 @@
         </p:nvSpPr>
         <p:spPr>
           <a:xfrm>
-            <a:off x="2286000" y="3794760"/>
-            <a:ext cx="7955280" cy="365760"/>
+            <a:off x="8869678" y="1783080"/>
+            <a:ext cx="2286000" cy="365760"/>
           </a:xfrm>
           <a:prstGeom prst="rect">
             <a:avLst/>
@@ -3877,7 +3877,7 @@
               </a:defRPr>
             </a:pPr>
             <a:r>
-              <a:t>Test</a:t>
+              <a:t>Implement</a:t>
             </a:r>
           </a:p>
         </p:txBody>
@@ -3890,8 +3890,8 @@
         </p:nvSpPr>
         <p:spPr>
           <a:xfrm>
-            <a:off x="2286000" y="4206240"/>
-            <a:ext cx="7955280" cy="457200"/>
+            <a:off x="8869678" y="2194560"/>
+            <a:ext cx="2286000" cy="457200"/>
           </a:xfrm>
           <a:prstGeom prst="rect">
             <a:avLst/>
@@ -3905,7 +3905,7 @@
           <a:lstStyle/>
           <a:p>
             <a:pPr algn="l">
-              <a:defRPr sz="1400" b="0">
+              <a:defRPr sz="1600" b="0">
                 <a:solidFill>
                   <a:srgbClr val="888899"/>
                 </a:solidFill>
@@ -3913,11 +3913,11 @@
               </a:defRPr>
             </a:pPr>
             <a:r>
-              <a:t>Write tests, deploy, run, self-heal</a:t>
+              <a:t>Write Apex, LWC,</a:t>
             </a:r>
             <a:br/>
             <a:r>
-              <a:t>on failures (max 3 iterations)</a:t>
+              <a:t>metadata</a:t>
             </a:r>
           </a:p>
         </p:txBody>
@@ -3930,8 +3930,8 @@
         </p:nvSpPr>
         <p:spPr>
           <a:xfrm>
-            <a:off x="1371600" y="4663440"/>
-            <a:ext cx="9144000" cy="1097280"/>
+            <a:off x="457200" y="4206240"/>
+            <a:ext cx="3474720" cy="1097280"/>
           </a:xfrm>
           <a:prstGeom prst="roundRect">
             <a:avLst/>
@@ -3974,14 +3974,14 @@
         </p:nvSpPr>
         <p:spPr>
           <a:xfrm>
-            <a:off x="1600200" y="4846320"/>
+            <a:off x="685800" y="4389120"/>
             <a:ext cx="548640" cy="548640"/>
           </a:xfrm>
           <a:prstGeom prst="ellipse">
             <a:avLst/>
           </a:prstGeom>
           <a:solidFill>
-            <a:srgbClr val="9B59B6"/>
+            <a:srgbClr val="E86C00"/>
           </a:solidFill>
           <a:ln>
             <a:noFill/>
@@ -4014,7 +4014,7 @@
               </a:defRPr>
             </a:pPr>
             <a:r>
-              <a:t>4</a:t>
+              <a:t>3</a:t>
             </a:r>
           </a:p>
         </p:txBody>
@@ -4027,8 +4027,8 @@
         </p:nvSpPr>
         <p:spPr>
           <a:xfrm>
-            <a:off x="2286000" y="4800600"/>
-            <a:ext cx="7955280" cy="365760"/>
+            <a:off x="1371600" y="4343400"/>
+            <a:ext cx="2286000" cy="365760"/>
           </a:xfrm>
           <a:prstGeom prst="rect">
             <a:avLst/>
@@ -4050,7 +4050,7 @@
               </a:defRPr>
             </a:pPr>
             <a:r>
-              <a:t>Validate</a:t>
+              <a:t>Test</a:t>
             </a:r>
           </a:p>
         </p:txBody>
@@ -4063,8 +4063,8 @@
         </p:nvSpPr>
         <p:spPr>
           <a:xfrm>
-            <a:off x="2286000" y="5212080"/>
-            <a:ext cx="7955280" cy="457200"/>
+            <a:off x="1371600" y="4754880"/>
+            <a:ext cx="2286000" cy="457200"/>
           </a:xfrm>
           <a:prstGeom prst="rect">
             <a:avLst/>
@@ -4078,7 +4078,7 @@
           <a:lstStyle/>
           <a:p>
             <a:pPr algn="l">
-              <a:defRPr sz="1400" b="0">
+              <a:defRPr sz="1600" b="0">
                 <a:solidFill>
                   <a:srgbClr val="888899"/>
                 </a:solidFill>
@@ -4086,11 +4086,11 @@
               </a:defRPr>
             </a:pPr>
             <a:r>
-              <a:t>Browser automation — navigate UI,</a:t>
+              <a:t>Deploy, run, self-heal</a:t>
             </a:r>
             <a:br/>
             <a:r>
-              <a:t>take screenshots, verify flow</a:t>
+              <a:t>(max 3 iterations)</a:t>
             </a:r>
           </a:p>
         </p:txBody>
@@ -4103,8 +4103,8 @@
         </p:nvSpPr>
         <p:spPr>
           <a:xfrm>
-            <a:off x="1371600" y="5669280"/>
-            <a:ext cx="9144000" cy="1097280"/>
+            <a:off x="4206239" y="4206240"/>
+            <a:ext cx="3474720" cy="1097280"/>
           </a:xfrm>
           <a:prstGeom prst="roundRect">
             <a:avLst/>
@@ -4147,7 +4147,180 @@
         </p:nvSpPr>
         <p:spPr>
           <a:xfrm>
-            <a:off x="1600200" y="5852160"/>
+            <a:off x="4434839" y="4389120"/>
+            <a:ext cx="548640" cy="548640"/>
+          </a:xfrm>
+          <a:prstGeom prst="ellipse">
+            <a:avLst/>
+          </a:prstGeom>
+          <a:solidFill>
+            <a:srgbClr val="9B59B6"/>
+          </a:solidFill>
+          <a:ln>
+            <a:noFill/>
+          </a:ln>
+        </p:spPr>
+        <p:style>
+          <a:lnRef idx="1">
+            <a:schemeClr val="accent1"/>
+          </a:lnRef>
+          <a:fillRef idx="3">
+            <a:schemeClr val="accent1"/>
+          </a:fillRef>
+          <a:effectRef idx="2">
+            <a:schemeClr val="accent1"/>
+          </a:effectRef>
+          <a:fontRef idx="minor">
+            <a:schemeClr val="lt1"/>
+          </a:fontRef>
+        </p:style>
+        <p:txBody>
+          <a:bodyPr rtlCol="0" anchor="ctr" wrap="none"/>
+          <a:lstStyle/>
+          <a:p>
+            <a:pPr algn="ctr">
+              <a:defRPr sz="2200" b="1">
+                <a:solidFill>
+                  <a:srgbClr val="FFFFFF"/>
+                </a:solidFill>
+                <a:latin typeface="Calibri"/>
+              </a:defRPr>
+            </a:pPr>
+            <a:r>
+              <a:t>4</a:t>
+            </a:r>
+          </a:p>
+        </p:txBody>
+      </p:sp>
+      <p:sp>
+        <p:nvSpPr>
+          <p:cNvPr id="23" name="TextBox 22"/>
+          <p:cNvSpPr txBox="1"/>
+          <p:nvPr/>
+        </p:nvSpPr>
+        <p:spPr>
+          <a:xfrm>
+            <a:off x="5120639" y="4343400"/>
+            <a:ext cx="2286000" cy="365760"/>
+          </a:xfrm>
+          <a:prstGeom prst="rect">
+            <a:avLst/>
+          </a:prstGeom>
+          <a:noFill/>
+        </p:spPr>
+        <p:txBody>
+          <a:bodyPr wrap="square">
+            <a:spAutoFit/>
+          </a:bodyPr>
+          <a:lstStyle/>
+          <a:p>
+            <a:pPr algn="l">
+              <a:defRPr sz="2000" b="1">
+                <a:solidFill>
+                  <a:srgbClr val="FFFFFF"/>
+                </a:solidFill>
+                <a:latin typeface="Calibri"/>
+              </a:defRPr>
+            </a:pPr>
+            <a:r>
+              <a:t>Validate</a:t>
+            </a:r>
+          </a:p>
+        </p:txBody>
+      </p:sp>
+      <p:sp>
+        <p:nvSpPr>
+          <p:cNvPr id="24" name="TextBox 23"/>
+          <p:cNvSpPr txBox="1"/>
+          <p:nvPr/>
+        </p:nvSpPr>
+        <p:spPr>
+          <a:xfrm>
+            <a:off x="5120639" y="4754880"/>
+            <a:ext cx="2286000" cy="457200"/>
+          </a:xfrm>
+          <a:prstGeom prst="rect">
+            <a:avLst/>
+          </a:prstGeom>
+          <a:noFill/>
+        </p:spPr>
+        <p:txBody>
+          <a:bodyPr wrap="square">
+            <a:spAutoFit/>
+          </a:bodyPr>
+          <a:lstStyle/>
+          <a:p>
+            <a:pPr algn="l">
+              <a:defRPr sz="1600" b="0">
+                <a:solidFill>
+                  <a:srgbClr val="888899"/>
+                </a:solidFill>
+                <a:latin typeface="Calibri"/>
+              </a:defRPr>
+            </a:pPr>
+            <a:r>
+              <a:t>Browser automation</a:t>
+            </a:r>
+            <a:br/>
+            <a:r>
+              <a:t>via Playwright</a:t>
+            </a:r>
+          </a:p>
+        </p:txBody>
+      </p:sp>
+      <p:sp>
+        <p:nvSpPr>
+          <p:cNvPr id="25" name="Rounded Rectangle 24"/>
+          <p:cNvSpPr/>
+          <p:nvPr/>
+        </p:nvSpPr>
+        <p:spPr>
+          <a:xfrm>
+            <a:off x="7955278" y="4206240"/>
+            <a:ext cx="3474720" cy="1097280"/>
+          </a:xfrm>
+          <a:prstGeom prst="roundRect">
+            <a:avLst/>
+          </a:prstGeom>
+          <a:solidFill>
+            <a:srgbClr val="25253E"/>
+          </a:solidFill>
+          <a:ln>
+            <a:noFill/>
+          </a:ln>
+          <a:effectLst/>
+        </p:spPr>
+        <p:style>
+          <a:lnRef idx="1">
+            <a:schemeClr val="accent1"/>
+          </a:lnRef>
+          <a:fillRef idx="3">
+            <a:schemeClr val="accent1"/>
+          </a:fillRef>
+          <a:effectRef idx="2">
+            <a:schemeClr val="accent1"/>
+          </a:effectRef>
+          <a:fontRef idx="minor">
+            <a:schemeClr val="lt1"/>
+          </a:fontRef>
+        </p:style>
+        <p:txBody>
+          <a:bodyPr rtlCol="0" anchor="ctr"/>
+          <a:lstStyle/>
+          <a:p>
+            <a:pPr algn="ctr"/>
+          </a:p>
+        </p:txBody>
+      </p:sp>
+      <p:sp>
+        <p:nvSpPr>
+          <p:cNvPr id="26" name="Oval 25"/>
+          <p:cNvSpPr/>
+          <p:nvPr/>
+        </p:nvSpPr>
+        <p:spPr>
+          <a:xfrm>
+            <a:off x="8183878" y="4389120"/>
             <a:ext cx="548640" cy="548640"/>
           </a:xfrm>
           <a:prstGeom prst="ellipse">
@@ -4194,14 +4367,14 @@
       </p:sp>
       <p:sp>
         <p:nvSpPr>
-          <p:cNvPr id="23" name="TextBox 22"/>
+          <p:cNvPr id="27" name="TextBox 26"/>
           <p:cNvSpPr txBox="1"/>
           <p:nvPr/>
         </p:nvSpPr>
         <p:spPr>
           <a:xfrm>
-            <a:off x="2286000" y="5806440"/>
-            <a:ext cx="7955280" cy="365760"/>
+            <a:off x="8869678" y="4343400"/>
+            <a:ext cx="2286000" cy="365760"/>
           </a:xfrm>
           <a:prstGeom prst="rect">
             <a:avLst/>
@@ -4223,21 +4396,21 @@
               </a:defRPr>
             </a:pPr>
             <a:r>
-              <a:t>Review &amp; Ship</a:t>
-            </a:r>
-          </a:p>
-        </p:txBody>
-      </p:sp>
-      <p:sp>
-        <p:nvSpPr>
-          <p:cNvPr id="24" name="TextBox 23"/>
+              <a:t>Ship</a:t>
+            </a:r>
+          </a:p>
+        </p:txBody>
+      </p:sp>
+      <p:sp>
+        <p:nvSpPr>
+          <p:cNvPr id="28" name="TextBox 27"/>
           <p:cNvSpPr txBox="1"/>
           <p:nvPr/>
         </p:nvSpPr>
         <p:spPr>
           <a:xfrm>
-            <a:off x="2286000" y="6217920"/>
-            <a:ext cx="7955280" cy="457200"/>
+            <a:off x="8869678" y="4754880"/>
+            <a:ext cx="2286000" cy="457200"/>
           </a:xfrm>
           <a:prstGeom prst="rect">
             <a:avLst/>
@@ -4251,7 +4424,7 @@
           <a:lstStyle/>
           <a:p>
             <a:pPr algn="l">
-              <a:defRPr sz="1400" b="0">
+              <a:defRPr sz="1600" b="0">
                 <a:solidFill>
                   <a:srgbClr val="888899"/>
                 </a:solidFill>
@@ -4259,184 +4432,12 @@
               </a:defRPr>
             </a:pPr>
             <a:r>
-              <a:t>Code review, format, commit,</a:t>
+              <a:t>Review, commit,</a:t>
             </a:r>
             <a:br/>
             <a:r>
               <a:t>push, open PR</a:t>
             </a:r>
-          </a:p>
-        </p:txBody>
-      </p:sp>
-      <p:sp>
-        <p:nvSpPr>
-          <p:cNvPr id="25" name="Down Arrow 24"/>
-          <p:cNvSpPr/>
-          <p:nvPr/>
-        </p:nvSpPr>
-        <p:spPr>
-          <a:xfrm>
-            <a:off x="5852160" y="2743200"/>
-            <a:ext cx="274320" cy="137160"/>
-          </a:xfrm>
-          <a:prstGeom prst="downArrow">
-            <a:avLst/>
-          </a:prstGeom>
-          <a:solidFill>
-            <a:srgbClr val="888899"/>
-          </a:solidFill>
-          <a:ln>
-            <a:noFill/>
-          </a:ln>
-        </p:spPr>
-        <p:style>
-          <a:lnRef idx="1">
-            <a:schemeClr val="accent1"/>
-          </a:lnRef>
-          <a:fillRef idx="3">
-            <a:schemeClr val="accent1"/>
-          </a:fillRef>
-          <a:effectRef idx="2">
-            <a:schemeClr val="accent1"/>
-          </a:effectRef>
-          <a:fontRef idx="minor">
-            <a:schemeClr val="lt1"/>
-          </a:fontRef>
-        </p:style>
-        <p:txBody>
-          <a:bodyPr rtlCol="0" anchor="ctr"/>
-          <a:lstStyle/>
-          <a:p>
-            <a:pPr algn="ctr"/>
-          </a:p>
-        </p:txBody>
-      </p:sp>
-      <p:sp>
-        <p:nvSpPr>
-          <p:cNvPr id="26" name="Down Arrow 25"/>
-          <p:cNvSpPr/>
-          <p:nvPr/>
-        </p:nvSpPr>
-        <p:spPr>
-          <a:xfrm>
-            <a:off x="5852160" y="3749040"/>
-            <a:ext cx="274320" cy="137160"/>
-          </a:xfrm>
-          <a:prstGeom prst="downArrow">
-            <a:avLst/>
-          </a:prstGeom>
-          <a:solidFill>
-            <a:srgbClr val="888899"/>
-          </a:solidFill>
-          <a:ln>
-            <a:noFill/>
-          </a:ln>
-        </p:spPr>
-        <p:style>
-          <a:lnRef idx="1">
-            <a:schemeClr val="accent1"/>
-          </a:lnRef>
-          <a:fillRef idx="3">
-            <a:schemeClr val="accent1"/>
-          </a:fillRef>
-          <a:effectRef idx="2">
-            <a:schemeClr val="accent1"/>
-          </a:effectRef>
-          <a:fontRef idx="minor">
-            <a:schemeClr val="lt1"/>
-          </a:fontRef>
-        </p:style>
-        <p:txBody>
-          <a:bodyPr rtlCol="0" anchor="ctr"/>
-          <a:lstStyle/>
-          <a:p>
-            <a:pPr algn="ctr"/>
-          </a:p>
-        </p:txBody>
-      </p:sp>
-      <p:sp>
-        <p:nvSpPr>
-          <p:cNvPr id="27" name="Down Arrow 26"/>
-          <p:cNvSpPr/>
-          <p:nvPr/>
-        </p:nvSpPr>
-        <p:spPr>
-          <a:xfrm>
-            <a:off x="5852160" y="4754880"/>
-            <a:ext cx="274320" cy="137160"/>
-          </a:xfrm>
-          <a:prstGeom prst="downArrow">
-            <a:avLst/>
-          </a:prstGeom>
-          <a:solidFill>
-            <a:srgbClr val="888899"/>
-          </a:solidFill>
-          <a:ln>
-            <a:noFill/>
-          </a:ln>
-        </p:spPr>
-        <p:style>
-          <a:lnRef idx="1">
-            <a:schemeClr val="accent1"/>
-          </a:lnRef>
-          <a:fillRef idx="3">
-            <a:schemeClr val="accent1"/>
-          </a:fillRef>
-          <a:effectRef idx="2">
-            <a:schemeClr val="accent1"/>
-          </a:effectRef>
-          <a:fontRef idx="minor">
-            <a:schemeClr val="lt1"/>
-          </a:fontRef>
-        </p:style>
-        <p:txBody>
-          <a:bodyPr rtlCol="0" anchor="ctr"/>
-          <a:lstStyle/>
-          <a:p>
-            <a:pPr algn="ctr"/>
-          </a:p>
-        </p:txBody>
-      </p:sp>
-      <p:sp>
-        <p:nvSpPr>
-          <p:cNvPr id="28" name="Down Arrow 27"/>
-          <p:cNvSpPr/>
-          <p:nvPr/>
-        </p:nvSpPr>
-        <p:spPr>
-          <a:xfrm>
-            <a:off x="5852160" y="5760720"/>
-            <a:ext cx="274320" cy="137160"/>
-          </a:xfrm>
-          <a:prstGeom prst="downArrow">
-            <a:avLst/>
-          </a:prstGeom>
-          <a:solidFill>
-            <a:srgbClr val="888899"/>
-          </a:solidFill>
-          <a:ln>
-            <a:noFill/>
-          </a:ln>
-        </p:spPr>
-        <p:style>
-          <a:lnRef idx="1">
-            <a:schemeClr val="accent1"/>
-          </a:lnRef>
-          <a:fillRef idx="3">
-            <a:schemeClr val="accent1"/>
-          </a:fillRef>
-          <a:effectRef idx="2">
-            <a:schemeClr val="accent1"/>
-          </a:effectRef>
-          <a:fontRef idx="minor">
-            <a:schemeClr val="lt1"/>
-          </a:fontRef>
-        </p:style>
-        <p:txBody>
-          <a:bodyPr rtlCol="0" anchor="ctr"/>
-          <a:lstStyle/>
-          <a:p>
-            <a:pPr algn="ctr"/>
           </a:p>
         </p:txBody>
       </p:sp>
@@ -8000,7 +8001,7 @@
               </a:defRPr>
             </a:pPr>
             <a:r>
-              <a:t>Invoice Payment Logging</a:t>
+              <a:t>Invoice Aging</a:t>
             </a:r>
           </a:p>
         </p:txBody>
@@ -8013,8 +8014,8 @@
         </p:nvSpPr>
         <p:spPr>
           <a:xfrm>
-            <a:off x="731520" y="2560320"/>
-            <a:ext cx="3017520" cy="3200400"/>
+            <a:off x="731520" y="2743200"/>
+            <a:ext cx="3017520" cy="1371600"/>
           </a:xfrm>
           <a:prstGeom prst="rect">
             <a:avLst/>
@@ -8027,143 +8028,16 @@
           </a:bodyPr>
           <a:lstStyle/>
           <a:p>
-            <a:pPr>
-              <a:spcBef>
-                <a:spcPts val="800"/>
-              </a:spcBef>
-              <a:spcAft>
-                <a:spcPts val="400"/>
-              </a:spcAft>
-            </a:pPr>
-            <a:r>
-              <a:rPr sz="1600">
-                <a:solidFill>
-                  <a:srgbClr val="00A1E0"/>
-                </a:solidFill>
-                <a:latin typeface="Calibri"/>
-              </a:rPr>
-              <a:t>▸ </a:t>
-            </a:r>
-            <a:r>
-              <a:rPr sz="1600">
-                <a:solidFill>
-                  <a:srgbClr val="CCCCCC"/>
-                </a:solidFill>
-                <a:latin typeface="Calibri"/>
-              </a:rPr>
-              <a:t>Payment__c object (child of Invoice)</a:t>
-            </a:r>
-          </a:p>
-          <a:p>
-            <a:pPr>
-              <a:spcBef>
-                <a:spcPts val="800"/>
-              </a:spcBef>
-              <a:spcAft>
-                <a:spcPts val="400"/>
-              </a:spcAft>
-            </a:pPr>
-            <a:r>
-              <a:rPr sz="1600">
-                <a:solidFill>
-                  <a:srgbClr val="00A1E0"/>
-                </a:solidFill>
-                <a:latin typeface="Calibri"/>
-              </a:rPr>
-              <a:t>▸ </a:t>
-            </a:r>
-            <a:r>
-              <a:rPr sz="1600">
-                <a:solidFill>
-                  <a:srgbClr val="CCCCCC"/>
-                </a:solidFill>
-                <a:latin typeface="Calibri"/>
-              </a:rPr>
-              <a:t>Auto-update status to Paid</a:t>
-            </a:r>
-          </a:p>
-          <a:p>
-            <a:pPr>
-              <a:spcBef>
-                <a:spcPts val="800"/>
-              </a:spcBef>
-              <a:spcAft>
-                <a:spcPts val="400"/>
-              </a:spcAft>
-            </a:pPr>
-            <a:r>
-              <a:rPr sz="1600">
-                <a:solidFill>
-                  <a:srgbClr val="00A1E0"/>
-                </a:solidFill>
-                <a:latin typeface="Calibri"/>
-              </a:rPr>
-              <a:t>▸ </a:t>
-            </a:r>
-            <a:r>
-              <a:rPr sz="1600">
-                <a:solidFill>
-                  <a:srgbClr val="CCCCCC"/>
-                </a:solidFill>
-                <a:latin typeface="Calibri"/>
-              </a:rPr>
-              <a:t>Revert on payment delete</a:t>
-            </a:r>
-          </a:p>
-          <a:p>
-            <a:pPr>
-              <a:spcBef>
-                <a:spcPts val="800"/>
-              </a:spcBef>
-              <a:spcAft>
-                <a:spcPts val="400"/>
-              </a:spcAft>
-            </a:pPr>
-            <a:r>
-              <a:rPr sz="1600">
-                <a:solidFill>
-                  <a:srgbClr val="00A1E0"/>
-                </a:solidFill>
-                <a:latin typeface="Calibri"/>
-              </a:rPr>
-              <a:t>▸ </a:t>
-            </a:r>
-            <a:r>
-              <a:rPr sz="1600">
-                <a:solidFill>
-                  <a:srgbClr val="CCCCCC"/>
-                </a:solidFill>
-                <a:latin typeface="Calibri"/>
-              </a:rPr>
-              <a:t>Validation rules</a:t>
-            </a:r>
-          </a:p>
-          <a:p>
-            <a:pPr>
-              <a:spcBef>
-                <a:spcPts val="800"/>
-              </a:spcBef>
-              <a:spcAft>
-                <a:spcPts val="400"/>
-              </a:spcAft>
-            </a:pPr>
-            <a:r>
-              <a:rPr sz="1600">
-                <a:solidFill>
-                  <a:srgbClr val="00A1E0"/>
-                </a:solidFill>
-                <a:latin typeface="Calibri"/>
-              </a:rPr>
-              <a:t>▸ </a:t>
-            </a:r>
-            <a:r>
-              <a:rPr sz="1600">
-                <a:solidFill>
-                  <a:srgbClr val="CCCCCC"/>
-                </a:solidFill>
-                <a:latin typeface="Calibri"/>
-              </a:rPr>
-              <a:t>LWC payment form + history</a:t>
+            <a:pPr algn="l">
+              <a:defRPr sz="1600" b="0">
+                <a:solidFill>
+                  <a:srgbClr val="888899"/>
+                </a:solidFill>
+                <a:latin typeface="Calibri"/>
+              </a:defRPr>
+            </a:pPr>
+            <a:r>
+              <a:t>As an account manager, I want to see an aging breakdown of unpaid invoices (Current, 1-30, 31-60, 61-90, 90+ days overdue) on the Account page, so I can prioritize collections and assess credit risk at a glance.</a:t>
             </a:r>
           </a:p>
         </p:txBody>
@@ -8292,8 +8166,8 @@
         </p:nvSpPr>
         <p:spPr>
           <a:xfrm>
-            <a:off x="4572000" y="2560320"/>
-            <a:ext cx="3017520" cy="3200400"/>
+            <a:off x="4572000" y="2743200"/>
+            <a:ext cx="3017520" cy="1371600"/>
           </a:xfrm>
           <a:prstGeom prst="rect">
             <a:avLst/>
@@ -8306,143 +8180,16 @@
           </a:bodyPr>
           <a:lstStyle/>
           <a:p>
-            <a:pPr>
-              <a:spcBef>
-                <a:spcPts val="800"/>
-              </a:spcBef>
-              <a:spcAft>
-                <a:spcPts val="400"/>
-              </a:spcAft>
-            </a:pPr>
-            <a:r>
-              <a:rPr sz="1600">
-                <a:solidFill>
-                  <a:srgbClr val="2ECC71"/>
-                </a:solidFill>
-                <a:latin typeface="Calibri"/>
-              </a:rPr>
-              <a:t>▸ </a:t>
-            </a:r>
-            <a:r>
-              <a:rPr sz="1600">
-                <a:solidFill>
-                  <a:srgbClr val="CCCCCC"/>
-                </a:solidFill>
-                <a:latin typeface="Calibri"/>
-              </a:rPr>
-              <a:t>InvoiceLineItem__c object</a:t>
-            </a:r>
-          </a:p>
-          <a:p>
-            <a:pPr>
-              <a:spcBef>
-                <a:spcPts val="800"/>
-              </a:spcBef>
-              <a:spcAft>
-                <a:spcPts val="400"/>
-              </a:spcAft>
-            </a:pPr>
-            <a:r>
-              <a:rPr sz="1600">
-                <a:solidFill>
-                  <a:srgbClr val="2ECC71"/>
-                </a:solidFill>
-                <a:latin typeface="Calibri"/>
-              </a:rPr>
-              <a:t>▸ </a:t>
-            </a:r>
-            <a:r>
-              <a:rPr sz="1600">
-                <a:solidFill>
-                  <a:srgbClr val="CCCCCC"/>
-                </a:solidFill>
-                <a:latin typeface="Calibri"/>
-              </a:rPr>
-              <a:t>Product, Quantity, Unit Price</a:t>
-            </a:r>
-          </a:p>
-          <a:p>
-            <a:pPr>
-              <a:spcBef>
-                <a:spcPts val="800"/>
-              </a:spcBef>
-              <a:spcAft>
-                <a:spcPts val="400"/>
-              </a:spcAft>
-            </a:pPr>
-            <a:r>
-              <a:rPr sz="1600">
-                <a:solidFill>
-                  <a:srgbClr val="2ECC71"/>
-                </a:solidFill>
-                <a:latin typeface="Calibri"/>
-              </a:rPr>
-              <a:t>▸ </a:t>
-            </a:r>
-            <a:r>
-              <a:rPr sz="1600">
-                <a:solidFill>
-                  <a:srgbClr val="CCCCCC"/>
-                </a:solidFill>
-                <a:latin typeface="Calibri"/>
-              </a:rPr>
-              <a:t>Roll-up to Invoice Amount</a:t>
-            </a:r>
-          </a:p>
-          <a:p>
-            <a:pPr>
-              <a:spcBef>
-                <a:spcPts val="800"/>
-              </a:spcBef>
-              <a:spcAft>
-                <a:spcPts val="400"/>
-              </a:spcAft>
-            </a:pPr>
-            <a:r>
-              <a:rPr sz="1600">
-                <a:solidFill>
-                  <a:srgbClr val="2ECC71"/>
-                </a:solidFill>
-                <a:latin typeface="Calibri"/>
-              </a:rPr>
-              <a:t>▸ </a:t>
-            </a:r>
-            <a:r>
-              <a:rPr sz="1600">
-                <a:solidFill>
-                  <a:srgbClr val="CCCCCC"/>
-                </a:solidFill>
-                <a:latin typeface="Calibri"/>
-              </a:rPr>
-              <a:t>Inline editing LWC</a:t>
-            </a:r>
-          </a:p>
-          <a:p>
-            <a:pPr>
-              <a:spcBef>
-                <a:spcPts val="800"/>
-              </a:spcBef>
-              <a:spcAft>
-                <a:spcPts val="400"/>
-              </a:spcAft>
-            </a:pPr>
-            <a:r>
-              <a:rPr sz="1600">
-                <a:solidFill>
-                  <a:srgbClr val="2ECC71"/>
-                </a:solidFill>
-                <a:latin typeface="Calibri"/>
-              </a:rPr>
-              <a:t>▸ </a:t>
-            </a:r>
-            <a:r>
-              <a:rPr sz="1600">
-                <a:solidFill>
-                  <a:srgbClr val="CCCCCC"/>
-                </a:solidFill>
-                <a:latin typeface="Calibri"/>
-              </a:rPr>
-              <a:t>Auto-recalculation trigger</a:t>
+            <a:pPr algn="l">
+              <a:defRPr sz="1600" b="0">
+                <a:solidFill>
+                  <a:srgbClr val="888899"/>
+                </a:solidFill>
+                <a:latin typeface="Calibri"/>
+              </a:defRPr>
+            </a:pPr>
+            <a:r>
+              <a:t>As a sales rep, I want to add line items to an invoice with product, quantity, and unit price, and have the invoice amount auto-calculate from the total, so that invoices are always accurate.</a:t>
             </a:r>
           </a:p>
         </p:txBody>
@@ -8558,7 +8305,7 @@
               </a:defRPr>
             </a:pPr>
             <a:r>
-              <a:t>Account Invoice Dashboard</a:t>
+              <a:t>Invoice Dashboard</a:t>
             </a:r>
           </a:p>
         </p:txBody>
@@ -8571,8 +8318,8 @@
         </p:nvSpPr>
         <p:spPr>
           <a:xfrm>
-            <a:off x="8412480" y="2560320"/>
-            <a:ext cx="3017520" cy="3200400"/>
+            <a:off x="8412480" y="2743200"/>
+            <a:ext cx="3017520" cy="1371600"/>
           </a:xfrm>
           <a:prstGeom prst="rect">
             <a:avLst/>
@@ -8585,143 +8332,16 @@
           </a:bodyPr>
           <a:lstStyle/>
           <a:p>
-            <a:pPr>
-              <a:spcBef>
-                <a:spcPts val="800"/>
-              </a:spcBef>
-              <a:spcAft>
-                <a:spcPts val="400"/>
-              </a:spcAft>
-            </a:pPr>
-            <a:r>
-              <a:rPr sz="1600">
-                <a:solidFill>
-                  <a:srgbClr val="9B59B6"/>
-                </a:solidFill>
-                <a:latin typeface="Calibri"/>
-              </a:rPr>
-              <a:t>▸ </a:t>
-            </a:r>
-            <a:r>
-              <a:rPr sz="1600">
-                <a:solidFill>
-                  <a:srgbClr val="CCCCCC"/>
-                </a:solidFill>
-                <a:latin typeface="Calibri"/>
-              </a:rPr>
-              <a:t>LWC on Account page</a:t>
-            </a:r>
-          </a:p>
-          <a:p>
-            <a:pPr>
-              <a:spcBef>
-                <a:spcPts val="800"/>
-              </a:spcBef>
-              <a:spcAft>
-                <a:spcPts val="400"/>
-              </a:spcAft>
-            </a:pPr>
-            <a:r>
-              <a:rPr sz="1600">
-                <a:solidFill>
-                  <a:srgbClr val="9B59B6"/>
-                </a:solidFill>
-                <a:latin typeface="Calibri"/>
-              </a:rPr>
-              <a:t>▸ </a:t>
-            </a:r>
-            <a:r>
-              <a:rPr sz="1600">
-                <a:solidFill>
-                  <a:srgbClr val="CCCCCC"/>
-                </a:solidFill>
-                <a:latin typeface="Calibri"/>
-              </a:rPr>
-              <a:t>Invoice counts by status</a:t>
-            </a:r>
-          </a:p>
-          <a:p>
-            <a:pPr>
-              <a:spcBef>
-                <a:spcPts val="800"/>
-              </a:spcBef>
-              <a:spcAft>
-                <a:spcPts val="400"/>
-              </a:spcAft>
-            </a:pPr>
-            <a:r>
-              <a:rPr sz="1600">
-                <a:solidFill>
-                  <a:srgbClr val="9B59B6"/>
-                </a:solidFill>
-                <a:latin typeface="Calibri"/>
-              </a:rPr>
-              <a:t>▸ </a:t>
-            </a:r>
-            <a:r>
-              <a:rPr sz="1600">
-                <a:solidFill>
-                  <a:srgbClr val="CCCCCC"/>
-                </a:solidFill>
-                <a:latin typeface="Calibri"/>
-              </a:rPr>
-              <a:t>Total outstanding amount</a:t>
-            </a:r>
-          </a:p>
-          <a:p>
-            <a:pPr>
-              <a:spcBef>
-                <a:spcPts val="800"/>
-              </a:spcBef>
-              <a:spcAft>
-                <a:spcPts val="400"/>
-              </a:spcAft>
-            </a:pPr>
-            <a:r>
-              <a:rPr sz="1600">
-                <a:solidFill>
-                  <a:srgbClr val="9B59B6"/>
-                </a:solidFill>
-                <a:latin typeface="Calibri"/>
-              </a:rPr>
-              <a:t>▸ </a:t>
-            </a:r>
-            <a:r>
-              <a:rPr sz="1600">
-                <a:solidFill>
-                  <a:srgbClr val="CCCCCC"/>
-                </a:solidFill>
-                <a:latin typeface="Calibri"/>
-              </a:rPr>
-              <a:t>Recent invoices table</a:t>
-            </a:r>
-          </a:p>
-          <a:p>
-            <a:pPr>
-              <a:spcBef>
-                <a:spcPts val="800"/>
-              </a:spcBef>
-              <a:spcAft>
-                <a:spcPts val="400"/>
-              </a:spcAft>
-            </a:pPr>
-            <a:r>
-              <a:rPr sz="1600">
-                <a:solidFill>
-                  <a:srgbClr val="9B59B6"/>
-                </a:solidFill>
-                <a:latin typeface="Calibri"/>
-              </a:rPr>
-              <a:t>▸ </a:t>
-            </a:r>
-            <a:r>
-              <a:rPr sz="1600">
-                <a:solidFill>
-                  <a:srgbClr val="CCCCCC"/>
-                </a:solidFill>
-                <a:latin typeface="Calibri"/>
-              </a:rPr>
-              <a:t>Visual status indicators</a:t>
+            <a:pPr algn="l">
+              <a:defRPr sz="1600" b="0">
+                <a:solidFill>
+                  <a:srgbClr val="888899"/>
+                </a:solidFill>
+                <a:latin typeface="Calibri"/>
+              </a:defRPr>
+            </a:pPr>
+            <a:r>
+              <a:t>As an account manager, I want to see a dashboard on the Account page showing invoice counts by status, total outstanding amount, and recent invoices, so I can assess a customer's financial health at a glance.</a:t>
             </a:r>
           </a:p>
         </p:txBody>
@@ -9780,7 +9400,7 @@
                 </a:solidFill>
                 <a:latin typeface="Calibri"/>
               </a:rPr>
-              <a:t>Every query uses the same</a:t>
+              <a:t>Every query uses the same fluent API pattern</a:t>
             </a:r>
           </a:p>
           <a:p>
@@ -9808,7 +9428,7 @@
                 </a:solidFill>
                 <a:latin typeface="Calibri"/>
               </a:rPr>
-              <a:t>fluent API pattern</a:t>
+              <a:t>AI learns ONE pattern, applies it everywhere</a:t>
             </a:r>
           </a:p>
           <a:p>
@@ -9836,9 +9456,112 @@
                 </a:solidFill>
                 <a:latin typeface="Calibri"/>
               </a:rPr>
-              <a:t/>
-            </a:r>
-          </a:p>
+              <a:t>No variation = fewer bugs</a:t>
+            </a:r>
+          </a:p>
+        </p:txBody>
+      </p:sp>
+      <p:sp>
+        <p:nvSpPr>
+          <p:cNvPr id="7" name="Rounded Rectangle 6"/>
+          <p:cNvSpPr/>
+          <p:nvPr/>
+        </p:nvSpPr>
+        <p:spPr>
+          <a:xfrm>
+            <a:off x="4297680" y="1645920"/>
+            <a:ext cx="3474720" cy="4754880"/>
+          </a:xfrm>
+          <a:prstGeom prst="roundRect">
+            <a:avLst/>
+          </a:prstGeom>
+          <a:solidFill>
+            <a:srgbClr val="25253E"/>
+          </a:solidFill>
+          <a:ln>
+            <a:noFill/>
+          </a:ln>
+          <a:effectLst/>
+        </p:spPr>
+        <p:style>
+          <a:lnRef idx="1">
+            <a:schemeClr val="accent1"/>
+          </a:lnRef>
+          <a:fillRef idx="3">
+            <a:schemeClr val="accent1"/>
+          </a:fillRef>
+          <a:effectRef idx="2">
+            <a:schemeClr val="accent1"/>
+          </a:effectRef>
+          <a:fontRef idx="minor">
+            <a:schemeClr val="lt1"/>
+          </a:fontRef>
+        </p:style>
+        <p:txBody>
+          <a:bodyPr rtlCol="0" anchor="ctr"/>
+          <a:lstStyle/>
+          <a:p>
+            <a:pPr algn="ctr"/>
+          </a:p>
+        </p:txBody>
+      </p:sp>
+      <p:sp>
+        <p:nvSpPr>
+          <p:cNvPr id="8" name="TextBox 7"/>
+          <p:cNvSpPr txBox="1"/>
+          <p:nvPr/>
+        </p:nvSpPr>
+        <p:spPr>
+          <a:xfrm>
+            <a:off x="4572000" y="1828800"/>
+            <a:ext cx="2926080" cy="457200"/>
+          </a:xfrm>
+          <a:prstGeom prst="rect">
+            <a:avLst/>
+          </a:prstGeom>
+          <a:noFill/>
+        </p:spPr>
+        <p:txBody>
+          <a:bodyPr wrap="square">
+            <a:spAutoFit/>
+          </a:bodyPr>
+          <a:lstStyle/>
+          <a:p>
+            <a:pPr algn="l">
+              <a:defRPr sz="2000" b="1">
+                <a:solidFill>
+                  <a:srgbClr val="2ECC71"/>
+                </a:solidFill>
+                <a:latin typeface="Calibri"/>
+              </a:defRPr>
+            </a:pPr>
+            <a:r>
+              <a:t>Mockability</a:t>
+            </a:r>
+          </a:p>
+        </p:txBody>
+      </p:sp>
+      <p:sp>
+        <p:nvSpPr>
+          <p:cNvPr id="9" name="TextBox 8"/>
+          <p:cNvSpPr txBox="1"/>
+          <p:nvPr/>
+        </p:nvSpPr>
+        <p:spPr>
+          <a:xfrm>
+            <a:off x="4572000" y="2286000"/>
+            <a:ext cx="2926080" cy="3931920"/>
+          </a:xfrm>
+          <a:prstGeom prst="rect">
+            <a:avLst/>
+          </a:prstGeom>
+          <a:noFill/>
+        </p:spPr>
+        <p:txBody>
+          <a:bodyPr wrap="square">
+            <a:spAutoFit/>
+          </a:bodyPr>
+          <a:lstStyle/>
           <a:p>
             <a:pPr>
               <a:spcBef>
@@ -9851,7 +9574,7 @@
             <a:r>
               <a:rPr sz="1600">
                 <a:solidFill>
-                  <a:srgbClr val="00A1E0"/>
+                  <a:srgbClr val="2ECC71"/>
                 </a:solidFill>
                 <a:latin typeface="Calibri"/>
               </a:rPr>
@@ -9864,7 +9587,7 @@
                 </a:solidFill>
                 <a:latin typeface="Calibri"/>
               </a:rPr>
-              <a:t>AI learns ONE pattern,</a:t>
+              <a:t>Every dependency can be mocked at the boundary</a:t>
             </a:r>
           </a:p>
           <a:p>
@@ -9879,7 +9602,7 @@
             <a:r>
               <a:rPr sz="1600">
                 <a:solidFill>
-                  <a:srgbClr val="00A1E0"/>
+                  <a:srgbClr val="2ECC71"/>
                 </a:solidFill>
                 <a:latin typeface="Calibri"/>
               </a:rPr>
@@ -9892,7 +9615,7 @@
                 </a:solidFill>
                 <a:latin typeface="Calibri"/>
               </a:rPr>
-              <a:t>applies it everywhere</a:t>
+              <a:t>Zero database hits in tests</a:t>
             </a:r>
           </a:p>
           <a:p>
@@ -9907,7 +9630,7 @@
             <a:r>
               <a:rPr sz="1600">
                 <a:solidFill>
-                  <a:srgbClr val="00A1E0"/>
+                  <a:srgbClr val="2ECC71"/>
                 </a:solidFill>
                 <a:latin typeface="Calibri"/>
               </a:rPr>
@@ -9920,9 +9643,112 @@
                 </a:solidFill>
                 <a:latin typeface="Calibri"/>
               </a:rPr>
-              <a:t/>
-            </a:r>
-          </a:p>
+              <a:t>AI can write tests without org state dependencies</a:t>
+            </a:r>
+          </a:p>
+        </p:txBody>
+      </p:sp>
+      <p:sp>
+        <p:nvSpPr>
+          <p:cNvPr id="10" name="Rounded Rectangle 9"/>
+          <p:cNvSpPr/>
+          <p:nvPr/>
+        </p:nvSpPr>
+        <p:spPr>
+          <a:xfrm>
+            <a:off x="8138160" y="1645920"/>
+            <a:ext cx="3474720" cy="4754880"/>
+          </a:xfrm>
+          <a:prstGeom prst="roundRect">
+            <a:avLst/>
+          </a:prstGeom>
+          <a:solidFill>
+            <a:srgbClr val="25253E"/>
+          </a:solidFill>
+          <a:ln>
+            <a:noFill/>
+          </a:ln>
+          <a:effectLst/>
+        </p:spPr>
+        <p:style>
+          <a:lnRef idx="1">
+            <a:schemeClr val="accent1"/>
+          </a:lnRef>
+          <a:fillRef idx="3">
+            <a:schemeClr val="accent1"/>
+          </a:fillRef>
+          <a:effectRef idx="2">
+            <a:schemeClr val="accent1"/>
+          </a:effectRef>
+          <a:fontRef idx="minor">
+            <a:schemeClr val="lt1"/>
+          </a:fontRef>
+        </p:style>
+        <p:txBody>
+          <a:bodyPr rtlCol="0" anchor="ctr"/>
+          <a:lstStyle/>
+          <a:p>
+            <a:pPr algn="ctr"/>
+          </a:p>
+        </p:txBody>
+      </p:sp>
+      <p:sp>
+        <p:nvSpPr>
+          <p:cNvPr id="11" name="TextBox 10"/>
+          <p:cNvSpPr txBox="1"/>
+          <p:nvPr/>
+        </p:nvSpPr>
+        <p:spPr>
+          <a:xfrm>
+            <a:off x="8412480" y="1828800"/>
+            <a:ext cx="2926080" cy="457200"/>
+          </a:xfrm>
+          <a:prstGeom prst="rect">
+            <a:avLst/>
+          </a:prstGeom>
+          <a:noFill/>
+        </p:spPr>
+        <p:txBody>
+          <a:bodyPr wrap="square">
+            <a:spAutoFit/>
+          </a:bodyPr>
+          <a:lstStyle/>
+          <a:p>
+            <a:pPr algn="l">
+              <a:defRPr sz="2000" b="1">
+                <a:solidFill>
+                  <a:srgbClr val="E86C00"/>
+                </a:solidFill>
+                <a:latin typeface="Calibri"/>
+              </a:defRPr>
+            </a:pPr>
+            <a:r>
+              <a:t>Guard Rails</a:t>
+            </a:r>
+          </a:p>
+        </p:txBody>
+      </p:sp>
+      <p:sp>
+        <p:nvSpPr>
+          <p:cNvPr id="12" name="TextBox 11"/>
+          <p:cNvSpPr txBox="1"/>
+          <p:nvPr/>
+        </p:nvSpPr>
+        <p:spPr>
+          <a:xfrm>
+            <a:off x="8412480" y="2286000"/>
+            <a:ext cx="2926080" cy="3931920"/>
+          </a:xfrm>
+          <a:prstGeom prst="rect">
+            <a:avLst/>
+          </a:prstGeom>
+          <a:noFill/>
+        </p:spPr>
+        <p:txBody>
+          <a:bodyPr wrap="square">
+            <a:spAutoFit/>
+          </a:bodyPr>
+          <a:lstStyle/>
           <a:p>
             <a:pPr>
               <a:spcBef>
@@ -9935,7 +9761,7 @@
             <a:r>
               <a:rPr sz="1600">
                 <a:solidFill>
-                  <a:srgbClr val="00A1E0"/>
+                  <a:srgbClr val="E86C00"/>
                 </a:solidFill>
                 <a:latin typeface="Calibri"/>
               </a:rPr>
@@ -9948,112 +9774,9 @@
                 </a:solidFill>
                 <a:latin typeface="Calibri"/>
               </a:rPr>
-              <a:t>No variation = fewer bugs</a:t>
-            </a:r>
-          </a:p>
-        </p:txBody>
-      </p:sp>
-      <p:sp>
-        <p:nvSpPr>
-          <p:cNvPr id="7" name="Rounded Rectangle 6"/>
-          <p:cNvSpPr/>
-          <p:nvPr/>
-        </p:nvSpPr>
-        <p:spPr>
-          <a:xfrm>
-            <a:off x="4297680" y="1645920"/>
-            <a:ext cx="3474720" cy="4754880"/>
-          </a:xfrm>
-          <a:prstGeom prst="roundRect">
-            <a:avLst/>
-          </a:prstGeom>
-          <a:solidFill>
-            <a:srgbClr val="25253E"/>
-          </a:solidFill>
-          <a:ln>
-            <a:noFill/>
-          </a:ln>
-          <a:effectLst/>
-        </p:spPr>
-        <p:style>
-          <a:lnRef idx="1">
-            <a:schemeClr val="accent1"/>
-          </a:lnRef>
-          <a:fillRef idx="3">
-            <a:schemeClr val="accent1"/>
-          </a:fillRef>
-          <a:effectRef idx="2">
-            <a:schemeClr val="accent1"/>
-          </a:effectRef>
-          <a:fontRef idx="minor">
-            <a:schemeClr val="lt1"/>
-          </a:fontRef>
-        </p:style>
-        <p:txBody>
-          <a:bodyPr rtlCol="0" anchor="ctr"/>
-          <a:lstStyle/>
-          <a:p>
-            <a:pPr algn="ctr"/>
-          </a:p>
-        </p:txBody>
-      </p:sp>
-      <p:sp>
-        <p:nvSpPr>
-          <p:cNvPr id="8" name="TextBox 7"/>
-          <p:cNvSpPr txBox="1"/>
-          <p:nvPr/>
-        </p:nvSpPr>
-        <p:spPr>
-          <a:xfrm>
-            <a:off x="4572000" y="1828800"/>
-            <a:ext cx="2926080" cy="457200"/>
-          </a:xfrm>
-          <a:prstGeom prst="rect">
-            <a:avLst/>
-          </a:prstGeom>
-          <a:noFill/>
-        </p:spPr>
-        <p:txBody>
-          <a:bodyPr wrap="square">
-            <a:spAutoFit/>
-          </a:bodyPr>
-          <a:lstStyle/>
-          <a:p>
-            <a:pPr algn="l">
-              <a:defRPr sz="2000" b="1">
-                <a:solidFill>
-                  <a:srgbClr val="2ECC71"/>
-                </a:solidFill>
-                <a:latin typeface="Calibri"/>
-              </a:defRPr>
-            </a:pPr>
-            <a:r>
-              <a:t>Mockability</a:t>
-            </a:r>
-          </a:p>
-        </p:txBody>
-      </p:sp>
-      <p:sp>
-        <p:nvSpPr>
-          <p:cNvPr id="9" name="TextBox 8"/>
-          <p:cNvSpPr txBox="1"/>
-          <p:nvPr/>
-        </p:nvSpPr>
-        <p:spPr>
-          <a:xfrm>
-            <a:off x="4572000" y="2286000"/>
-            <a:ext cx="2926080" cy="3931920"/>
-          </a:xfrm>
-          <a:prstGeom prst="rect">
-            <a:avLst/>
-          </a:prstGeom>
-          <a:noFill/>
-        </p:spPr>
-        <p:txBody>
-          <a:bodyPr wrap="square">
-            <a:spAutoFit/>
-          </a:bodyPr>
-          <a:lstStyle/>
+              <a:t>Hard rules the AI can follow:</a:t>
+            </a:r>
+          </a:p>
           <a:p>
             <a:pPr>
               <a:spcBef>
@@ -10066,7 +9789,7 @@
             <a:r>
               <a:rPr sz="1600">
                 <a:solidFill>
-                  <a:srgbClr val="2ECC71"/>
+                  <a:srgbClr val="E86C00"/>
                 </a:solidFill>
                 <a:latin typeface="Calibri"/>
               </a:rPr>
@@ -10079,7 +9802,7 @@
                 </a:solidFill>
                 <a:latin typeface="Calibri"/>
               </a:rPr>
-              <a:t>Every dependency can be</a:t>
+              <a:t>"Never write raw SOQL"</a:t>
             </a:r>
           </a:p>
           <a:p>
@@ -10094,7 +9817,7 @@
             <a:r>
               <a:rPr sz="1600">
                 <a:solidFill>
-                  <a:srgbClr val="2ECC71"/>
+                  <a:srgbClr val="E86C00"/>
                 </a:solidFill>
                 <a:latin typeface="Calibri"/>
               </a:rPr>
@@ -10107,7 +9830,7 @@
                 </a:solidFill>
                 <a:latin typeface="Calibri"/>
               </a:rPr>
-              <a:t>mocked at the boundary</a:t>
+              <a:t>"Never use raw DML"</a:t>
             </a:r>
           </a:p>
           <a:p>
@@ -10122,7 +9845,7 @@
             <a:r>
               <a:rPr sz="1600">
                 <a:solidFill>
-                  <a:srgbClr val="2ECC71"/>
+                  <a:srgbClr val="E86C00"/>
                 </a:solidFill>
                 <a:latin typeface="Calibri"/>
               </a:rPr>
@@ -10135,390 +9858,7 @@
                 </a:solidFill>
                 <a:latin typeface="Calibri"/>
               </a:rPr>
-              <a:t/>
-            </a:r>
-          </a:p>
-          <a:p>
-            <a:pPr>
-              <a:spcBef>
-                <a:spcPts val="800"/>
-              </a:spcBef>
-              <a:spcAft>
-                <a:spcPts val="400"/>
-              </a:spcAft>
-            </a:pPr>
-            <a:r>
-              <a:rPr sz="1600">
-                <a:solidFill>
-                  <a:srgbClr val="2ECC71"/>
-                </a:solidFill>
-                <a:latin typeface="Calibri"/>
-              </a:rPr>
-              <a:t>▸ </a:t>
-            </a:r>
-            <a:r>
-              <a:rPr sz="1600">
-                <a:solidFill>
-                  <a:srgbClr val="CCCCCC"/>
-                </a:solidFill>
-                <a:latin typeface="Calibri"/>
-              </a:rPr>
-              <a:t>Zero database hits in tests</a:t>
-            </a:r>
-          </a:p>
-          <a:p>
-            <a:pPr>
-              <a:spcBef>
-                <a:spcPts val="800"/>
-              </a:spcBef>
-              <a:spcAft>
-                <a:spcPts val="400"/>
-              </a:spcAft>
-            </a:pPr>
-            <a:r>
-              <a:rPr sz="1600">
-                <a:solidFill>
-                  <a:srgbClr val="2ECC71"/>
-                </a:solidFill>
-                <a:latin typeface="Calibri"/>
-              </a:rPr>
-              <a:t>▸ </a:t>
-            </a:r>
-            <a:r>
-              <a:rPr sz="1600">
-                <a:solidFill>
-                  <a:srgbClr val="CCCCCC"/>
-                </a:solidFill>
-                <a:latin typeface="Calibri"/>
-              </a:rPr>
-              <a:t/>
-            </a:r>
-          </a:p>
-          <a:p>
-            <a:pPr>
-              <a:spcBef>
-                <a:spcPts val="800"/>
-              </a:spcBef>
-              <a:spcAft>
-                <a:spcPts val="400"/>
-              </a:spcAft>
-            </a:pPr>
-            <a:r>
-              <a:rPr sz="1600">
-                <a:solidFill>
-                  <a:srgbClr val="2ECC71"/>
-                </a:solidFill>
-                <a:latin typeface="Calibri"/>
-              </a:rPr>
-              <a:t>▸ </a:t>
-            </a:r>
-            <a:r>
-              <a:rPr sz="1600">
-                <a:solidFill>
-                  <a:srgbClr val="CCCCCC"/>
-                </a:solidFill>
-                <a:latin typeface="Calibri"/>
-              </a:rPr>
-              <a:t>AI can write tests without</a:t>
-            </a:r>
-          </a:p>
-          <a:p>
-            <a:pPr>
-              <a:spcBef>
-                <a:spcPts val="800"/>
-              </a:spcBef>
-              <a:spcAft>
-                <a:spcPts val="400"/>
-              </a:spcAft>
-            </a:pPr>
-            <a:r>
-              <a:rPr sz="1600">
-                <a:solidFill>
-                  <a:srgbClr val="2ECC71"/>
-                </a:solidFill>
-                <a:latin typeface="Calibri"/>
-              </a:rPr>
-              <a:t>▸ </a:t>
-            </a:r>
-            <a:r>
-              <a:rPr sz="1600">
-                <a:solidFill>
-                  <a:srgbClr val="CCCCCC"/>
-                </a:solidFill>
-                <a:latin typeface="Calibri"/>
-              </a:rPr>
-              <a:t>org state dependencies</a:t>
-            </a:r>
-          </a:p>
-        </p:txBody>
-      </p:sp>
-      <p:sp>
-        <p:nvSpPr>
-          <p:cNvPr id="10" name="Rounded Rectangle 9"/>
-          <p:cNvSpPr/>
-          <p:nvPr/>
-        </p:nvSpPr>
-        <p:spPr>
-          <a:xfrm>
-            <a:off x="8138160" y="1645920"/>
-            <a:ext cx="3474720" cy="4754880"/>
-          </a:xfrm>
-          <a:prstGeom prst="roundRect">
-            <a:avLst/>
-          </a:prstGeom>
-          <a:solidFill>
-            <a:srgbClr val="25253E"/>
-          </a:solidFill>
-          <a:ln>
-            <a:noFill/>
-          </a:ln>
-          <a:effectLst/>
-        </p:spPr>
-        <p:style>
-          <a:lnRef idx="1">
-            <a:schemeClr val="accent1"/>
-          </a:lnRef>
-          <a:fillRef idx="3">
-            <a:schemeClr val="accent1"/>
-          </a:fillRef>
-          <a:effectRef idx="2">
-            <a:schemeClr val="accent1"/>
-          </a:effectRef>
-          <a:fontRef idx="minor">
-            <a:schemeClr val="lt1"/>
-          </a:fontRef>
-        </p:style>
-        <p:txBody>
-          <a:bodyPr rtlCol="0" anchor="ctr"/>
-          <a:lstStyle/>
-          <a:p>
-            <a:pPr algn="ctr"/>
-          </a:p>
-        </p:txBody>
-      </p:sp>
-      <p:sp>
-        <p:nvSpPr>
-          <p:cNvPr id="11" name="TextBox 10"/>
-          <p:cNvSpPr txBox="1"/>
-          <p:nvPr/>
-        </p:nvSpPr>
-        <p:spPr>
-          <a:xfrm>
-            <a:off x="8412480" y="1828800"/>
-            <a:ext cx="2926080" cy="457200"/>
-          </a:xfrm>
-          <a:prstGeom prst="rect">
-            <a:avLst/>
-          </a:prstGeom>
-          <a:noFill/>
-        </p:spPr>
-        <p:txBody>
-          <a:bodyPr wrap="square">
-            <a:spAutoFit/>
-          </a:bodyPr>
-          <a:lstStyle/>
-          <a:p>
-            <a:pPr algn="l">
-              <a:defRPr sz="2000" b="1">
-                <a:solidFill>
-                  <a:srgbClr val="E86C00"/>
-                </a:solidFill>
-                <a:latin typeface="Calibri"/>
-              </a:defRPr>
-            </a:pPr>
-            <a:r>
-              <a:t>Guard Rails</a:t>
-            </a:r>
-          </a:p>
-        </p:txBody>
-      </p:sp>
-      <p:sp>
-        <p:nvSpPr>
-          <p:cNvPr id="12" name="TextBox 11"/>
-          <p:cNvSpPr txBox="1"/>
-          <p:nvPr/>
-        </p:nvSpPr>
-        <p:spPr>
-          <a:xfrm>
-            <a:off x="8412480" y="2286000"/>
-            <a:ext cx="2926080" cy="3931920"/>
-          </a:xfrm>
-          <a:prstGeom prst="rect">
-            <a:avLst/>
-          </a:prstGeom>
-          <a:noFill/>
-        </p:spPr>
-        <p:txBody>
-          <a:bodyPr wrap="square">
-            <a:spAutoFit/>
-          </a:bodyPr>
-          <a:lstStyle/>
-          <a:p>
-            <a:pPr>
-              <a:spcBef>
-                <a:spcPts val="800"/>
-              </a:spcBef>
-              <a:spcAft>
-                <a:spcPts val="400"/>
-              </a:spcAft>
-            </a:pPr>
-            <a:r>
-              <a:rPr sz="1600">
-                <a:solidFill>
-                  <a:srgbClr val="E86C00"/>
-                </a:solidFill>
-                <a:latin typeface="Calibri"/>
-              </a:rPr>
-              <a:t>▸ </a:t>
-            </a:r>
-            <a:r>
-              <a:rPr sz="1600">
-                <a:solidFill>
-                  <a:srgbClr val="CCCCCC"/>
-                </a:solidFill>
-                <a:latin typeface="Calibri"/>
-              </a:rPr>
-              <a:t>Hard rules the AI can follow:</a:t>
-            </a:r>
-          </a:p>
-          <a:p>
-            <a:pPr>
-              <a:spcBef>
-                <a:spcPts val="800"/>
-              </a:spcBef>
-              <a:spcAft>
-                <a:spcPts val="400"/>
-              </a:spcAft>
-            </a:pPr>
-            <a:r>
-              <a:rPr sz="1600">
-                <a:solidFill>
-                  <a:srgbClr val="E86C00"/>
-                </a:solidFill>
-                <a:latin typeface="Calibri"/>
-              </a:rPr>
-              <a:t>▸ </a:t>
-            </a:r>
-            <a:r>
-              <a:rPr sz="1600">
-                <a:solidFill>
-                  <a:srgbClr val="CCCCCC"/>
-                </a:solidFill>
-                <a:latin typeface="Calibri"/>
-              </a:rPr>
-              <a:t>"Never write raw SOQL"</a:t>
-            </a:r>
-          </a:p>
-          <a:p>
-            <a:pPr>
-              <a:spcBef>
-                <a:spcPts val="800"/>
-              </a:spcBef>
-              <a:spcAft>
-                <a:spcPts val="400"/>
-              </a:spcAft>
-            </a:pPr>
-            <a:r>
-              <a:rPr sz="1600">
-                <a:solidFill>
-                  <a:srgbClr val="E86C00"/>
-                </a:solidFill>
-                <a:latin typeface="Calibri"/>
-              </a:rPr>
-              <a:t>▸ </a:t>
-            </a:r>
-            <a:r>
-              <a:rPr sz="1600">
-                <a:solidFill>
-                  <a:srgbClr val="CCCCCC"/>
-                </a:solidFill>
-                <a:latin typeface="Calibri"/>
-              </a:rPr>
-              <a:t>"Never use raw DML"</a:t>
-            </a:r>
-          </a:p>
-          <a:p>
-            <a:pPr>
-              <a:spcBef>
-                <a:spcPts val="800"/>
-              </a:spcBef>
-              <a:spcAft>
-                <a:spcPts val="400"/>
-              </a:spcAft>
-            </a:pPr>
-            <a:r>
-              <a:rPr sz="1600">
-                <a:solidFill>
-                  <a:srgbClr val="E86C00"/>
-                </a:solidFill>
-                <a:latin typeface="Calibri"/>
-              </a:rPr>
-              <a:t>▸ </a:t>
-            </a:r>
-            <a:r>
-              <a:rPr sz="1600">
-                <a:solidFill>
-                  <a:srgbClr val="CCCCCC"/>
-                </a:solidFill>
-                <a:latin typeface="Calibri"/>
-              </a:rPr>
-              <a:t/>
-            </a:r>
-          </a:p>
-          <a:p>
-            <a:pPr>
-              <a:spcBef>
-                <a:spcPts val="800"/>
-              </a:spcBef>
-              <a:spcAft>
-                <a:spcPts val="400"/>
-              </a:spcAft>
-            </a:pPr>
-            <a:r>
-              <a:rPr sz="1600">
-                <a:solidFill>
-                  <a:srgbClr val="E86C00"/>
-                </a:solidFill>
-                <a:latin typeface="Calibri"/>
-              </a:rPr>
-              <a:t>▸ </a:t>
-            </a:r>
-            <a:r>
-              <a:rPr sz="1600">
-                <a:solidFill>
-                  <a:srgbClr val="CCCCCC"/>
-                </a:solidFill>
-                <a:latin typeface="Calibri"/>
-              </a:rPr>
-              <a:t>Libraries enforce patterns</a:t>
-            </a:r>
-          </a:p>
-          <a:p>
-            <a:pPr>
-              <a:spcBef>
-                <a:spcPts val="800"/>
-              </a:spcBef>
-              <a:spcAft>
-                <a:spcPts val="400"/>
-              </a:spcAft>
-            </a:pPr>
-            <a:r>
-              <a:rPr sz="1600">
-                <a:solidFill>
-                  <a:srgbClr val="E86C00"/>
-                </a:solidFill>
-                <a:latin typeface="Calibri"/>
-              </a:rPr>
-              <a:t>▸ </a:t>
-            </a:r>
-            <a:r>
-              <a:rPr sz="1600">
-                <a:solidFill>
-                  <a:srgbClr val="CCCCCC"/>
-                </a:solidFill>
-                <a:latin typeface="Calibri"/>
-              </a:rPr>
-              <a:t>that prevent bad code</a:t>
+              <a:t>Libraries enforce patterns that prevent bad code</a:t>
             </a:r>
           </a:p>
         </p:txBody>
@@ -11630,11 +10970,7 @@
             </a:r>
             <a:br/>
             <a:r>
-              <a:t>    with(Account.Id, Account.Name)</a:t>
-            </a:r>
-            <a:br/>
-            <a:r>
-              <a:t>      .systemMode().withoutSharing();</a:t>
+              <a:t>    with(Account.Id, Account.Name);</a:t>
             </a:r>
             <a:br/>
             <a:r>
@@ -11878,7 +11214,7 @@
                 </a:solidFill>
                 <a:latin typeface="Calibri"/>
               </a:rPr>
-              <a:t>systemMode().withoutSharing()</a:t>
+              <a:t>Chainable filter methods</a:t>
             </a:r>
           </a:p>
           <a:p>
@@ -11906,63 +11242,7 @@
                 </a:solidFill>
                 <a:latin typeface="Calibri"/>
               </a:rPr>
-              <a:t>Chainable filter methods</a:t>
-            </a:r>
-          </a:p>
-          <a:p>
-            <a:pPr>
-              <a:spcBef>
-                <a:spcPts val="800"/>
-              </a:spcBef>
-              <a:spcAft>
-                <a:spcPts val="400"/>
-              </a:spcAft>
-            </a:pPr>
-            <a:r>
-              <a:rPr sz="1700">
-                <a:solidFill>
-                  <a:srgbClr val="E86C00"/>
-                </a:solidFill>
-                <a:latin typeface="Calibri"/>
-              </a:rPr>
-              <a:t>▸ </a:t>
-            </a:r>
-            <a:r>
-              <a:rPr sz="1700">
-                <a:solidFill>
-                  <a:srgbClr val="CCCCCC"/>
-                </a:solidFill>
-                <a:latin typeface="Calibri"/>
-              </a:rPr>
               <a:t>Return this for fluency</a:t>
-            </a:r>
-          </a:p>
-          <a:p>
-            <a:pPr>
-              <a:spcBef>
-                <a:spcPts val="800"/>
-              </a:spcBef>
-              <a:spcAft>
-                <a:spcPts val="400"/>
-              </a:spcAft>
-            </a:pPr>
-            <a:r>
-              <a:rPr sz="1700">
-                <a:solidFill>
-                  <a:srgbClr val="E86C00"/>
-                </a:solidFill>
-                <a:latin typeface="Calibri"/>
-              </a:rPr>
-              <a:t>▸ </a:t>
-            </a:r>
-            <a:r>
-              <a:rPr sz="1700">
-                <a:solidFill>
-                  <a:srgbClr val="CCCCCC"/>
-                </a:solidFill>
-                <a:latin typeface="Calibri"/>
-              </a:rPr>
-              <a:t/>
             </a:r>
           </a:p>
           <a:p>

</xml_diff>